<commit_message>
updated partcipants instruction manual
</commit_message>
<xml_diff>
--- a/Participants Instruction Manual.pptx
+++ b/Participants Instruction Manual.pptx
@@ -9510,8 +9510,8 @@
         </p:blipFill>
         <p:spPr>
           <a:xfrm>
-            <a:off x="3109825" y="137150"/>
-            <a:ext cx="5948575" cy="4888950"/>
+            <a:off x="3635575" y="94350"/>
+            <a:ext cx="4810437" cy="4838701"/>
           </a:xfrm>
           <a:prstGeom prst="rect">
             <a:avLst/>
@@ -9563,8 +9563,8 @@
         </p:blipFill>
         <p:spPr>
           <a:xfrm>
-            <a:off x="3038479" y="95325"/>
-            <a:ext cx="6062725" cy="5013749"/>
+            <a:off x="3298875" y="94350"/>
+            <a:ext cx="5335137" cy="4838699"/>
           </a:xfrm>
           <a:prstGeom prst="rect">
             <a:avLst/>
@@ -9616,8 +9616,8 @@
         </p:blipFill>
         <p:spPr>
           <a:xfrm>
-            <a:off x="3021350" y="62475"/>
-            <a:ext cx="6051326" cy="4994575"/>
+            <a:off x="3496275" y="152400"/>
+            <a:ext cx="5028686" cy="4838700"/>
           </a:xfrm>
           <a:prstGeom prst="rect">
             <a:avLst/>
@@ -9669,8 +9669,8 @@
         </p:blipFill>
         <p:spPr>
           <a:xfrm>
-            <a:off x="3122275" y="152400"/>
-            <a:ext cx="5905636" cy="4838700"/>
+            <a:off x="3078275" y="152400"/>
+            <a:ext cx="5899332" cy="4838700"/>
           </a:xfrm>
           <a:prstGeom prst="rect">
             <a:avLst/>

</xml_diff>